<commit_message>
Update slide day3 and starter files
</commit_message>
<xml_diff>
--- a/day3/Day3_MiniZinc_Slides.pptx
+++ b/day3/Day3_MiniZinc_Slides.pptx
@@ -10058,45 +10058,6 @@
       </p:sp>
       <p:sp>
         <p:nvSpPr>
-          <p:cNvPr id="13" name="Text 11"/>
-          <p:cNvSpPr/>
-          <p:nvPr/>
-        </p:nvSpPr>
-        <p:spPr>
-          <a:xfrm>
-            <a:off x="3291840" y="2514600"/>
-            <a:ext cx="5394960" cy="374904"/>
-          </a:xfrm>
-          <a:prstGeom prst="rect">
-            <a:avLst/>
-          </a:prstGeom>
-          <a:noFill/>
-          <a:ln/>
-        </p:spPr>
-        <p:txBody>
-          <a:bodyPr wrap="square" rtlCol="0" anchor="ctr"/>
-          <a:lstStyle/>
-          <a:p>
-            <a:pPr marL="0" indent="0">
-              <a:buNone/>
-            </a:pPr>
-            <a:r>
-              <a:rPr lang="en-US" sz="1050" dirty="0">
-                <a:solidFill>
-                  <a:srgbClr val="2D3748"/>
-                </a:solidFill>
-                <a:latin typeface="Consolas" pitchFamily="34" charset="0"/>
-                <a:ea typeface="Consolas" pitchFamily="34" charset="-122"/>
-                <a:cs typeface="Consolas" pitchFamily="34" charset="-120"/>
-              </a:rPr>
-              <a:t>S[j,1]+dur[j,1]&lt;=S[j,2]  และ  S[j,2]+dur[j,2]&lt;=S[j,3]  ทุก job</a:t>
-            </a:r>
-            <a:endParaRPr lang="en-US" sz="1050" dirty="0"/>
-          </a:p>
-        </p:txBody>
-      </p:sp>
-      <p:sp>
-        <p:nvSpPr>
           <p:cNvPr id="14" name="Shape 12"/>
           <p:cNvSpPr/>
           <p:nvPr/>
@@ -10229,45 +10190,6 @@
       </p:sp>
       <p:sp>
         <p:nvSpPr>
-          <p:cNvPr id="18" name="Text 16"/>
-          <p:cNvSpPr/>
-          <p:nvPr/>
-        </p:nvSpPr>
-        <p:spPr>
-          <a:xfrm>
-            <a:off x="3291840" y="2944368"/>
-            <a:ext cx="5394960" cy="374904"/>
-          </a:xfrm>
-          <a:prstGeom prst="rect">
-            <a:avLst/>
-          </a:prstGeom>
-          <a:noFill/>
-          <a:ln/>
-        </p:spPr>
-        <p:txBody>
-          <a:bodyPr wrap="square" rtlCol="0" anchor="ctr"/>
-          <a:lstStyle/>
-          <a:p>
-            <a:pPr marL="0" indent="0">
-              <a:buNone/>
-            </a:pPr>
-            <a:r>
-              <a:rPr lang="en-US" sz="1050" dirty="0">
-                <a:solidFill>
-                  <a:srgbClr val="2D3748"/>
-                </a:solidFill>
-                <a:latin typeface="Consolas" pitchFamily="34" charset="0"/>
-                <a:ea typeface="Consolas" pitchFamily="34" charset="-122"/>
-                <a:cs typeface="Consolas" pitchFamily="34" charset="-120"/>
-              </a:rPr>
-              <a:t>forall(t)(disjunctive([s[j,t]|j in 1..4],[dur[j,t]|j in 1..4]))</a:t>
-            </a:r>
-            <a:endParaRPr lang="en-US" sz="1050" dirty="0"/>
-          </a:p>
-        </p:txBody>
-      </p:sp>
-      <p:sp>
-        <p:nvSpPr>
           <p:cNvPr id="19" name="Shape 17"/>
           <p:cNvSpPr/>
           <p:nvPr/>
@@ -10395,45 +10317,6 @@
               <a:t>เพิ่ม makespan: </a:t>
             </a:r>
             <a:endParaRPr lang="en-US" sz="1150" dirty="0"/>
-          </a:p>
-        </p:txBody>
-      </p:sp>
-      <p:sp>
-        <p:nvSpPr>
-          <p:cNvPr id="23" name="Text 21"/>
-          <p:cNvSpPr/>
-          <p:nvPr/>
-        </p:nvSpPr>
-        <p:spPr>
-          <a:xfrm>
-            <a:off x="3291840" y="3374136"/>
-            <a:ext cx="5394960" cy="374904"/>
-          </a:xfrm>
-          <a:prstGeom prst="rect">
-            <a:avLst/>
-          </a:prstGeom>
-          <a:noFill/>
-          <a:ln/>
-        </p:spPr>
-        <p:txBody>
-          <a:bodyPr wrap="square" rtlCol="0" anchor="ctr"/>
-          <a:lstStyle/>
-          <a:p>
-            <a:pPr marL="0" indent="0">
-              <a:buNone/>
-            </a:pPr>
-            <a:r>
-              <a:rPr lang="en-US" sz="1050" dirty="0">
-                <a:solidFill>
-                  <a:srgbClr val="2D3748"/>
-                </a:solidFill>
-                <a:latin typeface="Consolas" pitchFamily="34" charset="0"/>
-                <a:ea typeface="Consolas" pitchFamily="34" charset="-122"/>
-                <a:cs typeface="Consolas" pitchFamily="34" charset="-120"/>
-              </a:rPr>
-              <a:t>s[j,3]+dur[j,3] &lt;= makespan  ทุก job  →  solve minimize makespan</a:t>
-            </a:r>
-            <a:endParaRPr lang="en-US" sz="1050" dirty="0"/>
           </a:p>
         </p:txBody>
       </p:sp>
@@ -24216,45 +24099,6 @@
       </p:sp>
       <p:sp>
         <p:nvSpPr>
-          <p:cNvPr id="13" name="Text 11"/>
-          <p:cNvSpPr/>
-          <p:nvPr/>
-        </p:nvSpPr>
-        <p:spPr>
-          <a:xfrm>
-            <a:off x="3657600" y="2542032"/>
-            <a:ext cx="5029200" cy="374904"/>
-          </a:xfrm>
-          <a:prstGeom prst="rect">
-            <a:avLst/>
-          </a:prstGeom>
-          <a:noFill/>
-          <a:ln/>
-        </p:spPr>
-        <p:txBody>
-          <a:bodyPr wrap="square" rtlCol="0" anchor="ctr"/>
-          <a:lstStyle/>
-          <a:p>
-            <a:pPr marL="0" indent="0">
-              <a:buNone/>
-            </a:pPr>
-            <a:r>
-              <a:rPr lang="en-US" sz="1050" dirty="0">
-                <a:solidFill>
-                  <a:srgbClr val="2D3748"/>
-                </a:solidFill>
-                <a:latin typeface="Consolas" pitchFamily="34" charset="0"/>
-                <a:ea typeface="Consolas" pitchFamily="34" charset="-122"/>
-                <a:cs typeface="Consolas" pitchFamily="34" charset="-120"/>
-              </a:rPr>
-              <a:t>constraint cumulative(start, dur, workers, total_workers);</a:t>
-            </a:r>
-            <a:endParaRPr lang="en-US" sz="1050" dirty="0"/>
-          </a:p>
-        </p:txBody>
-      </p:sp>
-      <p:sp>
-        <p:nvSpPr>
           <p:cNvPr id="14" name="Shape 12"/>
           <p:cNvSpPr/>
           <p:nvPr/>
@@ -24387,45 +24231,6 @@
       </p:sp>
       <p:sp>
         <p:nvSpPr>
-          <p:cNvPr id="18" name="Text 16"/>
-          <p:cNvSpPr/>
-          <p:nvPr/>
-        </p:nvSpPr>
-        <p:spPr>
-          <a:xfrm>
-            <a:off x="3657600" y="2971800"/>
-            <a:ext cx="5029200" cy="374904"/>
-          </a:xfrm>
-          <a:prstGeom prst="rect">
-            <a:avLst/>
-          </a:prstGeom>
-          <a:noFill/>
-          <a:ln/>
-        </p:spPr>
-        <p:txBody>
-          <a:bodyPr wrap="square" rtlCol="0" anchor="ctr"/>
-          <a:lstStyle/>
-          <a:p>
-            <a:pPr marL="0" indent="0">
-              <a:buNone/>
-            </a:pPr>
-            <a:r>
-              <a:rPr lang="en-US" sz="1050" dirty="0">
-                <a:solidFill>
-                  <a:srgbClr val="2D3748"/>
-                </a:solidFill>
-                <a:latin typeface="Consolas" pitchFamily="34" charset="0"/>
-                <a:ea typeface="Consolas" pitchFamily="34" charset="-122"/>
-                <a:cs typeface="Consolas" pitchFamily="34" charset="-120"/>
-              </a:rPr>
-              <a:t>constraint start[1] + dur[1] &lt;= start[3];</a:t>
-            </a:r>
-            <a:endParaRPr lang="en-US" sz="1050" dirty="0"/>
-          </a:p>
-        </p:txBody>
-      </p:sp>
-      <p:sp>
-        <p:nvSpPr>
           <p:cNvPr id="19" name="Shape 17"/>
           <p:cNvSpPr/>
           <p:nvPr/>
@@ -24558,45 +24363,6 @@
       </p:sp>
       <p:sp>
         <p:nvSpPr>
-          <p:cNvPr id="23" name="Text 21"/>
-          <p:cNvSpPr/>
-          <p:nvPr/>
-        </p:nvSpPr>
-        <p:spPr>
-          <a:xfrm>
-            <a:off x="3657600" y="3401568"/>
-            <a:ext cx="5029200" cy="374904"/>
-          </a:xfrm>
-          <a:prstGeom prst="rect">
-            <a:avLst/>
-          </a:prstGeom>
-          <a:noFill/>
-          <a:ln/>
-        </p:spPr>
-        <p:txBody>
-          <a:bodyPr wrap="square" rtlCol="0" anchor="ctr"/>
-          <a:lstStyle/>
-          <a:p>
-            <a:pPr marL="0" indent="0">
-              <a:buNone/>
-            </a:pPr>
-            <a:r>
-              <a:rPr lang="en-US" sz="1050" dirty="0">
-                <a:solidFill>
-                  <a:srgbClr val="2D3748"/>
-                </a:solidFill>
-                <a:latin typeface="Consolas" pitchFamily="34" charset="0"/>
-                <a:ea typeface="Consolas" pitchFamily="34" charset="-122"/>
-                <a:cs typeface="Consolas" pitchFamily="34" charset="-120"/>
-              </a:rPr>
-              <a:t>constraint forall(i in 1..6)(start[i] + dur[i] &lt;= end_time);</a:t>
-            </a:r>
-            <a:endParaRPr lang="en-US" sz="1050" dirty="0"/>
-          </a:p>
-        </p:txBody>
-      </p:sp>
-      <p:sp>
-        <p:nvSpPr>
           <p:cNvPr id="24" name="Shape 22"/>
           <p:cNvSpPr/>
           <p:nvPr/>
@@ -24729,45 +24495,6 @@
       </p:sp>
       <p:sp>
         <p:nvSpPr>
-          <p:cNvPr id="28" name="Text 26"/>
-          <p:cNvSpPr/>
-          <p:nvPr/>
-        </p:nvSpPr>
-        <p:spPr>
-          <a:xfrm>
-            <a:off x="3657600" y="3831336"/>
-            <a:ext cx="5029200" cy="374904"/>
-          </a:xfrm>
-          <a:prstGeom prst="rect">
-            <a:avLst/>
-          </a:prstGeom>
-          <a:noFill/>
-          <a:ln/>
-        </p:spPr>
-        <p:txBody>
-          <a:bodyPr wrap="square" rtlCol="0" anchor="ctr"/>
-          <a:lstStyle/>
-          <a:p>
-            <a:pPr marL="0" indent="0">
-              <a:buNone/>
-            </a:pPr>
-            <a:r>
-              <a:rPr lang="en-US" sz="1050" dirty="0">
-                <a:solidFill>
-                  <a:srgbClr val="2D3748"/>
-                </a:solidFill>
-                <a:latin typeface="Consolas" pitchFamily="34" charset="0"/>
-                <a:ea typeface="Consolas" pitchFamily="34" charset="-122"/>
-                <a:cs typeface="Consolas" pitchFamily="34" charset="-120"/>
-              </a:rPr>
-              <a:t>แก้ solve satisfy → solve minimize end_time;</a:t>
-            </a:r>
-            <a:endParaRPr lang="en-US" sz="1050" dirty="0"/>
-          </a:p>
-        </p:txBody>
-      </p:sp>
-      <p:sp>
-        <p:nvSpPr>
           <p:cNvPr id="29" name="Shape 27"/>
           <p:cNvSpPr/>
           <p:nvPr/>
@@ -24895,45 +24622,6 @@
               <a:t>(ท้าทาย) เพิ่ม D หลัง B: </a:t>
             </a:r>
             <a:endParaRPr lang="en-US" sz="1150" dirty="0"/>
-          </a:p>
-        </p:txBody>
-      </p:sp>
-      <p:sp>
-        <p:nvSpPr>
-          <p:cNvPr id="33" name="Text 31"/>
-          <p:cNvSpPr/>
-          <p:nvPr/>
-        </p:nvSpPr>
-        <p:spPr>
-          <a:xfrm>
-            <a:off x="3657600" y="4261104"/>
-            <a:ext cx="5029200" cy="374904"/>
-          </a:xfrm>
-          <a:prstGeom prst="rect">
-            <a:avLst/>
-          </a:prstGeom>
-          <a:noFill/>
-          <a:ln/>
-        </p:spPr>
-        <p:txBody>
-          <a:bodyPr wrap="square" rtlCol="0" anchor="ctr"/>
-          <a:lstStyle/>
-          <a:p>
-            <a:pPr marL="0" indent="0">
-              <a:buNone/>
-            </a:pPr>
-            <a:r>
-              <a:rPr lang="en-US" sz="1050" dirty="0">
-                <a:solidFill>
-                  <a:srgbClr val="2D3748"/>
-                </a:solidFill>
-                <a:latin typeface="Consolas" pitchFamily="34" charset="0"/>
-                <a:ea typeface="Consolas" pitchFamily="34" charset="-122"/>
-                <a:cs typeface="Consolas" pitchFamily="34" charset="-120"/>
-              </a:rPr>
-              <a:t>constraint start[2] + dur[2] &lt;= start[4];  — ผลเปลี่ยนไปไหม?</a:t>
-            </a:r>
-            <a:endParaRPr lang="en-US" sz="1050" dirty="0"/>
           </a:p>
         </p:txBody>
       </p:sp>

</xml_diff>

<commit_message>
fix error in slide day3
</commit_message>
<xml_diff>
--- a/day3/Day3_MiniZinc_Slides.pptx
+++ b/day3/Day3_MiniZinc_Slides.pptx
@@ -8982,7 +8982,7 @@
                 <a:ea typeface="Consolas" pitchFamily="34" charset="-122"/>
                 <a:cs typeface="Consolas" pitchFamily="34" charset="-120"/>
               </a:rPr>
-              <a:t>Makespan = 30 นาที</a:t>
+              <a:t>Makespan = 49 นาที</a:t>
             </a:r>
             <a:r>
               <a:rPr lang="en-US" sz="1050" dirty="0">
@@ -9053,7 +9053,7 @@
                 <a:ea typeface="Consolas" pitchFamily="34" charset="-122"/>
                 <a:cs typeface="Consolas" pitchFamily="34" charset="-120"/>
               </a:rPr>
-              <a:t> 1    5     9    17</a:t>
+              <a:t> 1    0    10    18</a:t>
             </a:r>
             <a:r>
               <a:rPr lang="en-US" sz="1050" dirty="0">
@@ -9082,7 +9082,7 @@
                 <a:ea typeface="Consolas" pitchFamily="34" charset="-122"/>
                 <a:cs typeface="Consolas" pitchFamily="34" charset="-120"/>
               </a:rPr>
-              <a:t> 2    0    10    25</a:t>
+              <a:t> 2   22    29    44</a:t>
             </a:r>
             <a:r>
               <a:rPr lang="en-US" sz="1050" dirty="0">
@@ -9111,7 +9111,7 @@
                 <a:ea typeface="Consolas" pitchFamily="34" charset="-122"/>
                 <a:cs typeface="Consolas" pitchFamily="34" charset="-120"/>
               </a:rPr>
-              <a:t> 3    0     7    13</a:t>
+              <a:t> 3   10    22    30</a:t>
             </a:r>
             <a:endParaRPr lang="en-US" sz="1050" dirty="0"/>
           </a:p>
@@ -10656,7 +10656,29 @@
                 <a:ea typeface="Consolas" pitchFamily="34" charset="-122"/>
                 <a:cs typeface="Consolas" pitchFamily="34" charset="-120"/>
               </a:rPr>
-              <a:t>D ต้องเริ่ม S1 ไม่ก่อนนาทีที่ 5  →  makespan เปลี่ยนไปไหม?</a:t>
+              <a:t>D ต้องเริ่ม S1 </a:t>
+            </a:r>
+            <a:r>
+              <a:rPr lang="en-US" sz="1050" dirty="0" err="1">
+                <a:solidFill>
+                  <a:srgbClr val="2D3748"/>
+                </a:solidFill>
+                <a:latin typeface="Consolas" pitchFamily="34" charset="0"/>
+                <a:ea typeface="Consolas" pitchFamily="34" charset="-122"/>
+                <a:cs typeface="Consolas" pitchFamily="34" charset="-120"/>
+              </a:rPr>
+              <a:t>ก่อนนาทีที่</a:t>
+            </a:r>
+            <a:r>
+              <a:rPr lang="en-US" sz="1050" dirty="0">
+                <a:solidFill>
+                  <a:srgbClr val="2D3748"/>
+                </a:solidFill>
+                <a:latin typeface="Consolas" pitchFamily="34" charset="0"/>
+                <a:ea typeface="Consolas" pitchFamily="34" charset="-122"/>
+                <a:cs typeface="Consolas" pitchFamily="34" charset="-120"/>
+              </a:rPr>
+              <a:t> 5  →  makespan เปลี่ยนไปไหม?</a:t>
             </a:r>
             <a:endParaRPr lang="en-US" sz="1050" dirty="0"/>
           </a:p>
@@ -24619,7 +24641,84 @@
                 <a:ea typeface="Calibri" pitchFamily="34" charset="-122"/>
                 <a:cs typeface="Calibri" pitchFamily="34" charset="-120"/>
               </a:rPr>
-              <a:t>(ท้าทาย) เพิ่ม D หลัง B: </a:t>
+              <a:t>(ท้าทาย) </a:t>
+            </a:r>
+            <a:r>
+              <a:rPr lang="en-US" sz="1150" b="1" dirty="0" err="1">
+                <a:solidFill>
+                  <a:srgbClr val="1A3C5E"/>
+                </a:solidFill>
+                <a:latin typeface="Calibri" pitchFamily="34" charset="0"/>
+                <a:ea typeface="Calibri" pitchFamily="34" charset="-122"/>
+                <a:cs typeface="Calibri" pitchFamily="34" charset="-120"/>
+              </a:rPr>
+              <a:t>เพิ่ม</a:t>
+            </a:r>
+            <a:r>
+              <a:rPr lang="en-US" sz="1150" b="1" dirty="0">
+                <a:solidFill>
+                  <a:srgbClr val="1A3C5E"/>
+                </a:solidFill>
+                <a:latin typeface="Calibri" pitchFamily="34" charset="0"/>
+                <a:ea typeface="Calibri" pitchFamily="34" charset="-122"/>
+                <a:cs typeface="Calibri" pitchFamily="34" charset="-120"/>
+              </a:rPr>
+              <a:t> B </a:t>
+            </a:r>
+            <a:r>
+              <a:rPr lang="th-TH" sz="1150" b="1" dirty="0">
+                <a:solidFill>
+                  <a:srgbClr val="1A3C5E"/>
+                </a:solidFill>
+                <a:latin typeface="Calibri" pitchFamily="34" charset="0"/>
+                <a:ea typeface="Calibri" pitchFamily="34" charset="-122"/>
+                <a:cs typeface="Calibri" pitchFamily="34" charset="-120"/>
+              </a:rPr>
+              <a:t>ต้องทำ</a:t>
+            </a:r>
+            <a:r>
+              <a:rPr lang="en-US" sz="1150" b="1" dirty="0" err="1">
+                <a:solidFill>
+                  <a:srgbClr val="1A3C5E"/>
+                </a:solidFill>
+                <a:latin typeface="Calibri" pitchFamily="34" charset="0"/>
+                <a:ea typeface="Calibri" pitchFamily="34" charset="-122"/>
+                <a:cs typeface="Calibri" pitchFamily="34" charset="-120"/>
+              </a:rPr>
+              <a:t>หลัง</a:t>
+            </a:r>
+            <a:r>
+              <a:rPr lang="en-US" sz="1150" b="1" dirty="0">
+                <a:solidFill>
+                  <a:srgbClr val="1A3C5E"/>
+                </a:solidFill>
+                <a:latin typeface="Calibri" pitchFamily="34" charset="0"/>
+                <a:ea typeface="Calibri" pitchFamily="34" charset="-122"/>
+                <a:cs typeface="Calibri" pitchFamily="34" charset="-120"/>
+              </a:rPr>
+              <a:t> D</a:t>
+            </a:r>
+            <a:r>
+              <a:rPr lang="th-TH" sz="1150" b="1" dirty="0">
+                <a:solidFill>
+                  <a:srgbClr val="1A3C5E"/>
+                </a:solidFill>
+                <a:latin typeface="Calibri" pitchFamily="34" charset="0"/>
+                <a:ea typeface="Calibri" pitchFamily="34" charset="-122"/>
+                <a:cs typeface="Calibri" pitchFamily="34" charset="-120"/>
+              </a:rPr>
+              <a:t> เสร็จ</a:t>
+            </a:r>
+            <a:r>
+              <a:rPr lang="en-US" sz="1150" b="1" dirty="0">
+                <a:solidFill>
+                  <a:srgbClr val="1A3C5E"/>
+                </a:solidFill>
+                <a:latin typeface="Calibri" pitchFamily="34" charset="0"/>
+                <a:ea typeface="Calibri" pitchFamily="34" charset="-122"/>
+                <a:cs typeface="Calibri" pitchFamily="34" charset="-120"/>
+              </a:rPr>
+              <a:t>: </a:t>
             </a:r>
             <a:endParaRPr lang="en-US" sz="1150" dirty="0"/>
           </a:p>

</xml_diff>